<commit_message>
Update 포커페이스 assets and add ZIP slides
Co-Authored-By: Claude Opus 4.6 (1M context) <noreply@anthropic.com>
</commit_message>
<xml_diff>
--- a/public/downloads/games/poker-face/rules.pptx
+++ b/public/downloads/games/poker-face/rules.pptx
@@ -14,16 +14,12 @@
   <p:notesSz cx="6858000" cy="9144000"/>
   <p:embeddedFontLst>
     <p:embeddedFont>
-      <p:font typeface="Jua" charset="1" panose="00000000000000000000"/>
+      <p:font typeface="무궁화 고딕" charset="1" panose="02020603020101020101"/>
       <p:regular r:id="rId10"/>
     </p:embeddedFont>
     <p:embeddedFont>
-      <p:font typeface="TDTD갬성명조" charset="1" panose="02000503000000000000"/>
+      <p:font typeface="무궁화 고딕 Bold" charset="1" panose="02020603020101020101"/>
       <p:regular r:id="rId11"/>
-    </p:embeddedFont>
-    <p:embeddedFont>
-      <p:font typeface="TDTD가온" charset="1" panose="02000503000000000000"/>
-      <p:regular r:id="rId12"/>
     </p:embeddedFont>
   </p:embeddedFontLst>
   <p:defaultTextStyle>
@@ -3141,8 +3137,8 @@
         </p:nvSpPr>
         <p:spPr>
           <a:xfrm rot="0">
-            <a:off x="1028700" y="3892867"/>
-            <a:ext cx="15555091" cy="2200275"/>
+            <a:off x="1028700" y="4178617"/>
+            <a:ext cx="15555091" cy="1914525"/>
           </a:xfrm>
           <a:prstGeom prst="rect">
             <a:avLst/>
@@ -3164,10 +3160,10 @@
                 <a:solidFill>
                   <a:srgbClr val="FFFAEF"/>
                 </a:solidFill>
-                <a:latin typeface="Jua"/>
-                <a:ea typeface="Jua"/>
-                <a:cs typeface="Jua"/>
-                <a:sym typeface="Jua"/>
+                <a:latin typeface="무궁화 고딕"/>
+                <a:ea typeface="무궁화 고딕"/>
+                <a:cs typeface="무궁화 고딕"/>
+                <a:sym typeface="무궁화 고딕"/>
               </a:rPr>
               <a:t>포커페이스</a:t>
             </a:r>
@@ -3182,8 +3178,8 @@
         </p:nvSpPr>
         <p:spPr>
           <a:xfrm rot="0">
-            <a:off x="15264803" y="9812655"/>
-            <a:ext cx="2637975" cy="474345"/>
+            <a:off x="14542909" y="9822180"/>
+            <a:ext cx="3359870" cy="464820"/>
           </a:xfrm>
           <a:prstGeom prst="rect">
             <a:avLst/>
@@ -3208,10 +3204,10 @@
                 <a:solidFill>
                   <a:srgbClr val="FFFFFF"/>
                 </a:solidFill>
-                <a:latin typeface="TDTD갬성명조"/>
-                <a:ea typeface="TDTD갬성명조"/>
-                <a:cs typeface="TDTD갬성명조"/>
-                <a:sym typeface="TDTD갬성명조"/>
+                <a:latin typeface="무궁화 고딕"/>
+                <a:ea typeface="무궁화 고딕"/>
+                <a:cs typeface="무궁화 고딕"/>
+                <a:sym typeface="무궁화 고딕"/>
               </a:rPr>
               <a:t>ⓒ 2026. Sunday Play</a:t>
             </a:r>
@@ -3360,8 +3356,8 @@
         </p:nvSpPr>
         <p:spPr>
           <a:xfrm rot="0">
-            <a:off x="11392761" y="600705"/>
-            <a:ext cx="5362043" cy="1600200"/>
+            <a:off x="11392761" y="819780"/>
+            <a:ext cx="5362043" cy="1381125"/>
           </a:xfrm>
           <a:prstGeom prst="rect">
             <a:avLst/>
@@ -3383,10 +3379,10 @@
                 <a:solidFill>
                   <a:srgbClr val="FFFAEF"/>
                 </a:solidFill>
-                <a:latin typeface="Jua"/>
-                <a:ea typeface="Jua"/>
-                <a:cs typeface="Jua"/>
-                <a:sym typeface="Jua"/>
+                <a:latin typeface="무궁화 고딕"/>
+                <a:ea typeface="무궁화 고딕"/>
+                <a:cs typeface="무궁화 고딕"/>
+                <a:sym typeface="무궁화 고딕"/>
               </a:rPr>
               <a:t>규칙</a:t>
             </a:r>
@@ -3402,9 +3398,9 @@
         <p:grpSpPr>
           <a:xfrm rot="0">
             <a:off x="309172" y="535073"/>
-            <a:ext cx="12078314" cy="2573620"/>
+            <a:ext cx="12078314" cy="2406534"/>
             <a:chOff x="0" y="0"/>
-            <a:chExt cx="16104419" cy="3431493"/>
+            <a:chExt cx="16104419" cy="3208711"/>
           </a:xfrm>
         </p:grpSpPr>
         <p:sp>
@@ -3415,8 +3411,8 @@
           </p:nvSpPr>
           <p:spPr>
             <a:xfrm rot="0">
-              <a:off x="0" y="1380584"/>
-              <a:ext cx="16104419" cy="2050910"/>
+              <a:off x="0" y="1388378"/>
+              <a:ext cx="16104419" cy="1820333"/>
             </a:xfrm>
             <a:prstGeom prst="rect">
               <a:avLst/>
@@ -3430,18 +3426,18 @@
             <a:p>
               <a:pPr algn="l">
                 <a:lnSpc>
-                  <a:spcPts val="6273"/>
+                  <a:spcPts val="5599"/>
                 </a:lnSpc>
               </a:pPr>
               <a:r>
-                <a:rPr lang="en-US" sz="4480">
+                <a:rPr lang="en-US" sz="3999">
                   <a:solidFill>
                     <a:srgbClr val="FFFAEF"/>
                   </a:solidFill>
-                  <a:latin typeface="TDTD가온"/>
-                  <a:ea typeface="TDTD가온"/>
-                  <a:cs typeface="TDTD가온"/>
-                  <a:sym typeface="TDTD가온"/>
+                  <a:latin typeface="무궁화 고딕"/>
+                  <a:ea typeface="무궁화 고딕"/>
+                  <a:cs typeface="무궁화 고딕"/>
+                  <a:sym typeface="무궁화 고딕"/>
                 </a:rPr>
                 <a:t>탐정은 눈을 감고, 한 사람이 동전을 한쪽 손에 쥡니다.                             </a:t>
               </a:r>
@@ -3449,30 +3445,30 @@
             <a:p>
               <a:pPr algn="l">
                 <a:lnSpc>
-                  <a:spcPts val="6273"/>
+                  <a:spcPts val="5599"/>
                 </a:lnSpc>
               </a:pPr>
               <a:r>
-                <a:rPr lang="en-US" sz="4480">
+                <a:rPr lang="en-US" sz="3999">
                   <a:solidFill>
                     <a:srgbClr val="FFFAEF"/>
                   </a:solidFill>
-                  <a:latin typeface="TDTD가온"/>
-                  <a:ea typeface="TDTD가온"/>
-                  <a:cs typeface="TDTD가온"/>
-                  <a:sym typeface="TDTD가온"/>
+                  <a:latin typeface="무궁화 고딕"/>
+                  <a:ea typeface="무궁화 고딕"/>
+                  <a:cs typeface="무궁화 고딕"/>
+                  <a:sym typeface="무궁화 고딕"/>
                 </a:rPr>
                 <a:t>모두 양 주먹을 내밀어</a:t>
               </a:r>
               <a:r>
-                <a:rPr lang="en-US" sz="4480">
+                <a:rPr lang="en-US" sz="3999">
                   <a:solidFill>
                     <a:srgbClr val="FFFAEF"/>
                   </a:solidFill>
-                  <a:latin typeface="TDTD가온"/>
-                  <a:ea typeface="TDTD가온"/>
-                  <a:cs typeface="TDTD가온"/>
-                  <a:sym typeface="TDTD가온"/>
+                  <a:latin typeface="무궁화 고딕"/>
+                  <a:ea typeface="무궁화 고딕"/>
+                  <a:cs typeface="무궁화 고딕"/>
+                  <a:sym typeface="무궁화 고딕"/>
                 </a:rPr>
                 <a:t> 주세요.</a:t>
               </a:r>
@@ -3487,8 +3483,8 @@
           </p:nvSpPr>
           <p:spPr>
             <a:xfrm rot="0">
-              <a:off x="0" y="-171450"/>
-              <a:ext cx="9574913" cy="1169217"/>
+              <a:off x="0" y="-66675"/>
+              <a:ext cx="9574913" cy="1062712"/>
             </a:xfrm>
             <a:prstGeom prst="rect">
               <a:avLst/>
@@ -3510,10 +3506,10 @@
                   <a:solidFill>
                     <a:srgbClr val="FFFAEF"/>
                   </a:solidFill>
-                  <a:latin typeface="Jua"/>
-                  <a:ea typeface="Jua"/>
-                  <a:cs typeface="Jua"/>
-                  <a:sym typeface="Jua"/>
+                  <a:latin typeface="무궁화 고딕 Bold"/>
+                  <a:ea typeface="무궁화 고딕 Bold"/>
+                  <a:cs typeface="무궁화 고딕 Bold"/>
+                  <a:sym typeface="무궁화 고딕 Bold"/>
                 </a:rPr>
                 <a:t>STEP 1.</a:t>
               </a:r>
@@ -3529,10 +3525,10 @@
         </p:nvGrpSpPr>
         <p:grpSpPr>
           <a:xfrm rot="0">
-            <a:off x="10809792" y="7503133"/>
-            <a:ext cx="7083439" cy="2574122"/>
+            <a:off x="10910055" y="7583343"/>
+            <a:ext cx="7083439" cy="2402712"/>
             <a:chOff x="0" y="0"/>
-            <a:chExt cx="9444586" cy="3432162"/>
+            <a:chExt cx="9444586" cy="3203616"/>
           </a:xfrm>
         </p:grpSpPr>
         <p:sp>
@@ -3543,8 +3539,8 @@
           </p:nvSpPr>
           <p:spPr>
             <a:xfrm rot="0">
-              <a:off x="0" y="1377534"/>
-              <a:ext cx="9300195" cy="2054628"/>
+              <a:off x="0" y="1373758"/>
+              <a:ext cx="9300195" cy="1829858"/>
             </a:xfrm>
             <a:prstGeom prst="rect">
               <a:avLst/>
@@ -3558,30 +3554,30 @@
             <a:p>
               <a:pPr algn="l">
                 <a:lnSpc>
-                  <a:spcPts val="6284"/>
+                  <a:spcPts val="5600"/>
                 </a:lnSpc>
               </a:pPr>
               <a:r>
-                <a:rPr lang="en-US" sz="4489">
+                <a:rPr lang="en-US" sz="4000">
                   <a:solidFill>
                     <a:srgbClr val="FFFAEF"/>
                   </a:solidFill>
-                  <a:latin typeface="TDTD가온"/>
-                  <a:ea typeface="TDTD가온"/>
-                  <a:cs typeface="TDTD가온"/>
-                  <a:sym typeface="TDTD가온"/>
+                  <a:latin typeface="무궁화 고딕"/>
+                  <a:ea typeface="무궁화 고딕"/>
+                  <a:cs typeface="무궁화 고딕"/>
+                  <a:sym typeface="무궁화 고딕"/>
                 </a:rPr>
                 <a:t>돌아가며 탐정을 하고,</a:t>
               </a:r>
               <a:r>
-                <a:rPr lang="en-US" sz="4489">
+                <a:rPr lang="en-US" sz="4000">
                   <a:solidFill>
                     <a:srgbClr val="FFFAEF"/>
                   </a:solidFill>
-                  <a:latin typeface="TDTD가온"/>
-                  <a:ea typeface="TDTD가온"/>
-                  <a:cs typeface="TDTD가온"/>
-                  <a:sym typeface="TDTD가온"/>
+                  <a:latin typeface="무궁화 고딕"/>
+                  <a:ea typeface="무궁화 고딕"/>
+                  <a:cs typeface="무궁화 고딕"/>
+                  <a:sym typeface="무궁화 고딕"/>
                 </a:rPr>
                 <a:t> 누적 점수가 가장 높은 사람이 우승!</a:t>
               </a:r>
@@ -3596,8 +3592,8 @@
           </p:nvSpPr>
           <p:spPr>
             <a:xfrm rot="0">
-              <a:off x="0" y="-171450"/>
-              <a:ext cx="9444586" cy="1171105"/>
+              <a:off x="0" y="-57150"/>
+              <a:ext cx="9444586" cy="1053029"/>
             </a:xfrm>
             <a:prstGeom prst="rect">
               <a:avLst/>
@@ -3619,10 +3615,10 @@
                   <a:solidFill>
                     <a:srgbClr val="FFFAEF"/>
                   </a:solidFill>
-                  <a:latin typeface="Jua"/>
-                  <a:ea typeface="Jua"/>
-                  <a:cs typeface="Jua"/>
-                  <a:sym typeface="Jua"/>
+                  <a:latin typeface="무궁화 고딕 Bold"/>
+                  <a:ea typeface="무궁화 고딕 Bold"/>
+                  <a:cs typeface="무궁화 고딕 Bold"/>
+                  <a:sym typeface="무궁화 고딕 Bold"/>
                 </a:rPr>
                 <a:t>STEP 3.</a:t>
               </a:r>
@@ -3638,10 +3634,10 @@
         </p:nvGrpSpPr>
         <p:grpSpPr>
           <a:xfrm rot="0">
-            <a:off x="4621704" y="3960731"/>
-            <a:ext cx="10397630" cy="3364141"/>
+            <a:off x="4054144" y="3708919"/>
+            <a:ext cx="10397630" cy="3107111"/>
             <a:chOff x="0" y="0"/>
-            <a:chExt cx="13863507" cy="4485521"/>
+            <a:chExt cx="13863507" cy="4142815"/>
           </a:xfrm>
         </p:grpSpPr>
         <p:sp>
@@ -3652,8 +3648,8 @@
           </p:nvSpPr>
           <p:spPr>
             <a:xfrm rot="0">
-              <a:off x="0" y="1375218"/>
-              <a:ext cx="13863507" cy="3110303"/>
+              <a:off x="0" y="1382681"/>
+              <a:ext cx="13863507" cy="2760133"/>
             </a:xfrm>
             <a:prstGeom prst="rect">
               <a:avLst/>
@@ -3667,18 +3663,18 @@
             <a:p>
               <a:pPr algn="l">
                 <a:lnSpc>
-                  <a:spcPts val="6275"/>
+                  <a:spcPts val="5599"/>
                 </a:lnSpc>
               </a:pPr>
               <a:r>
-                <a:rPr lang="en-US" sz="4482">
+                <a:rPr lang="en-US" sz="3999">
                   <a:solidFill>
                     <a:srgbClr val="FFFAEF"/>
                   </a:solidFill>
-                  <a:latin typeface="TDTD가온"/>
-                  <a:ea typeface="TDTD가온"/>
-                  <a:cs typeface="TDTD가온"/>
-                  <a:sym typeface="TDTD가온"/>
+                  <a:latin typeface="무궁화 고딕"/>
+                  <a:ea typeface="무궁화 고딕"/>
+                  <a:cs typeface="무궁화 고딕"/>
+                  <a:sym typeface="무궁화 고딕"/>
                 </a:rPr>
                 <a:t>탐정이 왼손 또는 오른손을 지목합니다.                                      </a:t>
               </a:r>
@@ -3686,18 +3682,18 @@
             <a:p>
               <a:pPr algn="l">
                 <a:lnSpc>
-                  <a:spcPts val="6275"/>
+                  <a:spcPts val="5599"/>
                 </a:lnSpc>
               </a:pPr>
               <a:r>
-                <a:rPr lang="en-US" sz="4482">
+                <a:rPr lang="en-US" sz="3999">
                   <a:solidFill>
                     <a:srgbClr val="FFFAEF"/>
                   </a:solidFill>
-                  <a:latin typeface="TDTD가온"/>
-                  <a:ea typeface="TDTD가온"/>
-                  <a:cs typeface="TDTD가온"/>
-                  <a:sym typeface="TDTD가온"/>
+                  <a:latin typeface="무궁화 고딕"/>
+                  <a:ea typeface="무궁화 고딕"/>
+                  <a:cs typeface="무궁화 고딕"/>
+                  <a:sym typeface="무궁화 고딕"/>
                 </a:rPr>
                 <a:t>동전 발견 → +50점! 빈 손 → -10점!             </a:t>
               </a:r>
@@ -3705,18 +3701,18 @@
             <a:p>
               <a:pPr algn="l">
                 <a:lnSpc>
-                  <a:spcPts val="6275"/>
+                  <a:spcPts val="5599"/>
                 </a:lnSpc>
               </a:pPr>
               <a:r>
-                <a:rPr lang="en-US" sz="4482">
+                <a:rPr lang="en-US" sz="3999">
                   <a:solidFill>
                     <a:srgbClr val="FFFAEF"/>
                   </a:solidFill>
-                  <a:latin typeface="TDTD가온"/>
-                  <a:ea typeface="TDTD가온"/>
-                  <a:cs typeface="TDTD가온"/>
-                  <a:sym typeface="TDTD가온"/>
+                  <a:latin typeface="무궁화 고딕"/>
+                  <a:ea typeface="무궁화 고딕"/>
+                  <a:cs typeface="무궁화 고딕"/>
+                  <a:sym typeface="무궁화 고딕"/>
                 </a:rPr>
                 <a:t>"스톱"을 외치면 현재 점수 확정!</a:t>
               </a:r>
@@ -3731,8 +3727,8 @@
           </p:nvSpPr>
           <p:spPr>
             <a:xfrm rot="0">
-              <a:off x="0" y="-171450"/>
-              <a:ext cx="6898637" cy="1169523"/>
+              <a:off x="0" y="-57150"/>
+              <a:ext cx="6898637" cy="1053161"/>
             </a:xfrm>
             <a:prstGeom prst="rect">
               <a:avLst/>
@@ -3754,10 +3750,10 @@
                   <a:solidFill>
                     <a:srgbClr val="FFFAEF"/>
                   </a:solidFill>
-                  <a:latin typeface="Jua"/>
-                  <a:ea typeface="Jua"/>
-                  <a:cs typeface="Jua"/>
-                  <a:sym typeface="Jua"/>
+                  <a:latin typeface="무궁화 고딕 Bold"/>
+                  <a:ea typeface="무궁화 고딕 Bold"/>
+                  <a:cs typeface="무궁화 고딕 Bold"/>
+                  <a:sym typeface="무궁화 고딕 Bold"/>
                 </a:rPr>
                 <a:t>STEP 2.</a:t>
               </a:r>
@@ -3855,8 +3851,8 @@
         </p:nvSpPr>
         <p:spPr>
           <a:xfrm rot="0">
-            <a:off x="1028700" y="3892867"/>
-            <a:ext cx="15555091" cy="2200275"/>
+            <a:off x="1028700" y="4178617"/>
+            <a:ext cx="15555091" cy="1914525"/>
           </a:xfrm>
           <a:prstGeom prst="rect">
             <a:avLst/>
@@ -3878,10 +3874,10 @@
                 <a:solidFill>
                   <a:srgbClr val="FFFAEF"/>
                 </a:solidFill>
-                <a:latin typeface="Jua"/>
-                <a:ea typeface="Jua"/>
-                <a:cs typeface="Jua"/>
-                <a:sym typeface="Jua"/>
+                <a:latin typeface="무궁화 고딕"/>
+                <a:ea typeface="무궁화 고딕"/>
+                <a:cs typeface="무궁화 고딕"/>
+                <a:sym typeface="무궁화 고딕"/>
               </a:rPr>
               <a:t>포커페이스</a:t>
             </a:r>
@@ -3896,8 +3892,8 @@
         </p:nvSpPr>
         <p:spPr>
           <a:xfrm rot="0">
-            <a:off x="15264803" y="9812655"/>
-            <a:ext cx="2637975" cy="474345"/>
+            <a:off x="14542909" y="9822180"/>
+            <a:ext cx="3359870" cy="464820"/>
           </a:xfrm>
           <a:prstGeom prst="rect">
             <a:avLst/>
@@ -3922,10 +3918,10 @@
                 <a:solidFill>
                   <a:srgbClr val="FFFFFF"/>
                 </a:solidFill>
-                <a:latin typeface="TDTD갬성명조"/>
-                <a:ea typeface="TDTD갬성명조"/>
-                <a:cs typeface="TDTD갬성명조"/>
-                <a:sym typeface="TDTD갬성명조"/>
+                <a:latin typeface="무궁화 고딕"/>
+                <a:ea typeface="무궁화 고딕"/>
+                <a:cs typeface="무궁화 고딕"/>
+                <a:sym typeface="무궁화 고딕"/>
               </a:rPr>
               <a:t>ⓒ 2026. Sunday Play</a:t>
             </a:r>
@@ -3997,8 +3993,8 @@
         </p:nvSpPr>
         <p:spPr>
           <a:xfrm rot="0">
-            <a:off x="4421807" y="3895725"/>
-            <a:ext cx="9444385" cy="2200275"/>
+            <a:off x="4421807" y="4181475"/>
+            <a:ext cx="9444385" cy="1914525"/>
           </a:xfrm>
           <a:prstGeom prst="rect">
             <a:avLst/>
@@ -4020,10 +4016,10 @@
                 <a:solidFill>
                   <a:srgbClr val="000000"/>
                 </a:solidFill>
-                <a:latin typeface="Jua"/>
-                <a:ea typeface="Jua"/>
-                <a:cs typeface="Jua"/>
-                <a:sym typeface="Jua"/>
+                <a:latin typeface="무궁화 고딕"/>
+                <a:ea typeface="무궁화 고딕"/>
+                <a:cs typeface="무궁화 고딕"/>
+                <a:sym typeface="무궁화 고딕"/>
               </a:rPr>
               <a:t>감사합니다!</a:t>
             </a:r>

</xml_diff>